<commit_message>
Scheduled snapshot t12 (2026-07-17): fresh IG/FB/YT/TT + rebuilt decks
Co-Authored-By: Claude Opus 4.7 (1M context) <noreply@anthropic.com>
</commit_message>
<xml_diff>
--- a/MONTHLY_REPORT_2026-07.pptx
+++ b/MONTHLY_REPORT_2026-07.pptx
@@ -4709,7 +4709,7 @@
                 </a:solidFill>
                 <a:latin typeface="Georgia"/>
               </a:rPr>
-              <a:t>42,450</a:t>
+              <a:t>42,480</a:t>
             </a:r>
           </a:p>
         </p:txBody>
@@ -5045,7 +5045,7 @@
                 </a:solidFill>
                 <a:latin typeface="Georgia"/>
               </a:rPr>
-              <a:t>40,666</a:t>
+              <a:t>40,667</a:t>
             </a:r>
           </a:p>
         </p:txBody>
@@ -5381,7 +5381,7 @@
                 </a:solidFill>
                 <a:latin typeface="Georgia"/>
               </a:rPr>
-              <a:t>24,841</a:t>
+              <a:t>24,842</a:t>
             </a:r>
           </a:p>
         </p:txBody>
@@ -6319,7 +6319,7 @@
                 </a:solidFill>
                 <a:latin typeface="Helvetica Neue"/>
               </a:rPr>
-              <a:t>10 posts · 55,879 total views</a:t>
+              <a:t>10 posts · 55,883 total views</a:t>
             </a:r>
           </a:p>
         </p:txBody>
@@ -6475,7 +6475,7 @@
                 </a:solidFill>
                 <a:latin typeface="Georgia"/>
               </a:rPr>
-              <a:t>642</a:t>
+              <a:t>643</a:t>
             </a:r>
           </a:p>
         </p:txBody>
@@ -6543,7 +6543,7 @@
                 </a:solidFill>
                 <a:latin typeface="Helvetica Neue"/>
               </a:rPr>
-              <a:t>33 posts · 21,193 total views</a:t>
+              <a:t>33 posts · 21,204 total views</a:t>
             </a:r>
           </a:p>
         </p:txBody>
@@ -6767,7 +6767,7 @@
                 </a:solidFill>
                 <a:latin typeface="Helvetica Neue"/>
               </a:rPr>
-              <a:t>9 posts · 8,163 total views</a:t>
+              <a:t>9 posts · 8,164 total views</a:t>
             </a:r>
           </a:p>
         </p:txBody>
@@ -6991,7 +6991,7 @@
                 </a:solidFill>
                 <a:latin typeface="Helvetica Neue"/>
               </a:rPr>
-              <a:t>13 posts · 4,805 total views</a:t>
+              <a:t>13 posts · 4,814 total views</a:t>
             </a:r>
           </a:p>
         </p:txBody>
@@ -7215,7 +7215,7 @@
                 </a:solidFill>
                 <a:latin typeface="Helvetica Neue"/>
               </a:rPr>
-              <a:t>4 posts · 4,777 total views</a:t>
+              <a:t>4 posts · 4,778 total views</a:t>
             </a:r>
           </a:p>
         </p:txBody>
@@ -7439,7 +7439,7 @@
                 </a:solidFill>
                 <a:latin typeface="Helvetica Neue"/>
               </a:rPr>
-              <a:t>8 posts · 4,391 total views</a:t>
+              <a:t>8 posts · 4,393 total views</a:t>
             </a:r>
           </a:p>
         </p:txBody>
@@ -7887,7 +7887,7 @@
                 </a:solidFill>
                 <a:latin typeface="Helvetica Neue"/>
               </a:rPr>
-              <a:t>4 posts · 2,016 total views</a:t>
+              <a:t>4 posts · 2,018 total views</a:t>
             </a:r>
           </a:p>
         </p:txBody>
@@ -9301,7 +9301,7 @@
                 </a:solidFill>
                 <a:latin typeface="Helvetica Neue"/>
               </a:rPr>
-              <a:t>5,136</a:t>
+              <a:t>5,142</a:t>
             </a:r>
           </a:p>
         </p:txBody>

</xml_diff>

<commit_message>
Scheduled snapshot t13 (2026-07-20): fresh IG/FB/YT/TT + rebuilt decks
Co-Authored-By: Claude Opus 4.7 (1M context) <noreply@anthropic.com>
</commit_message>
<xml_diff>
--- a/MONTHLY_REPORT_2026-07.pptx
+++ b/MONTHLY_REPORT_2026-07.pptx
@@ -3613,7 +3613,7 @@
                 </a:solidFill>
                 <a:latin typeface="Georgia"/>
               </a:rPr>
-              <a:t>92</a:t>
+              <a:t>100</a:t>
             </a:r>
           </a:p>
         </p:txBody>
@@ -4063,7 +4063,7 @@
                 </a:solidFill>
                 <a:latin typeface="Georgia"/>
               </a:rPr>
-              <a:t>1,121 → 504</a:t>
+              <a:t>1,121 → 515</a:t>
             </a:r>
           </a:p>
         </p:txBody>
@@ -4097,7 +4097,7 @@
                 </a:solidFill>
                 <a:latin typeface="Helvetica Neue"/>
               </a:rPr>
-              <a:t>▼ -55%</a:t>
+              <a:t>▼ -54%</a:t>
             </a:r>
           </a:p>
         </p:txBody>
@@ -4287,7 +4287,7 @@
                 </a:solidFill>
                 <a:latin typeface="Georgia"/>
               </a:rPr>
-              <a:t>632 → 489</a:t>
+              <a:t>632 → 491</a:t>
             </a:r>
           </a:p>
         </p:txBody>
@@ -4321,7 +4321,7 @@
                 </a:solidFill>
                 <a:latin typeface="Helvetica Neue"/>
               </a:rPr>
-              <a:t>▼ -23%</a:t>
+              <a:t>▼ -22%</a:t>
             </a:r>
           </a:p>
         </p:txBody>
@@ -4709,7 +4709,7 @@
                 </a:solidFill>
                 <a:latin typeface="Georgia"/>
               </a:rPr>
-              <a:t>42,480</a:t>
+              <a:t>44,836</a:t>
             </a:r>
           </a:p>
         </p:txBody>
@@ -4743,7 +4743,7 @@
                 </a:solidFill>
                 <a:latin typeface="Helvetica Neue"/>
               </a:rPr>
-              <a:t>July views (30 posts)</a:t>
+              <a:t>July views (33 posts)</a:t>
             </a:r>
           </a:p>
         </p:txBody>
@@ -5045,7 +5045,7 @@
                 </a:solidFill>
                 <a:latin typeface="Georgia"/>
               </a:rPr>
-              <a:t>40,667</a:t>
+              <a:t>41,546</a:t>
             </a:r>
           </a:p>
         </p:txBody>
@@ -5079,7 +5079,7 @@
                 </a:solidFill>
                 <a:latin typeface="Helvetica Neue"/>
               </a:rPr>
-              <a:t>July views (28 posts)</a:t>
+              <a:t>July views (30 posts)</a:t>
             </a:r>
           </a:p>
         </p:txBody>
@@ -5381,7 +5381,7 @@
                 </a:solidFill>
                 <a:latin typeface="Georgia"/>
               </a:rPr>
-              <a:t>24,842</a:t>
+              <a:t>25,984</a:t>
             </a:r>
           </a:p>
         </p:txBody>
@@ -5415,7 +5415,7 @@
                 </a:solidFill>
                 <a:latin typeface="Helvetica Neue"/>
               </a:rPr>
-              <a:t>July views (31 posts)</a:t>
+              <a:t>July views (34 posts)</a:t>
             </a:r>
           </a:p>
         </p:txBody>
@@ -5717,7 +5717,7 @@
                 </a:solidFill>
                 <a:latin typeface="Georgia"/>
               </a:rPr>
-              <a:t>190</a:t>
+              <a:t>200</a:t>
             </a:r>
           </a:p>
         </p:txBody>
@@ -5863,7 +5863,7 @@
                 </a:solidFill>
                 <a:latin typeface="Helvetica Neue"/>
               </a:rPr>
-              <a:t>702</a:t>
+              <a:t>707</a:t>
             </a:r>
           </a:p>
         </p:txBody>
@@ -6251,7 +6251,7 @@
                 </a:solidFill>
                 <a:latin typeface="Georgia"/>
               </a:rPr>
-              <a:t>5,588</a:t>
+              <a:t>5,623</a:t>
             </a:r>
           </a:p>
         </p:txBody>
@@ -6319,7 +6319,7 @@
                 </a:solidFill>
                 <a:latin typeface="Helvetica Neue"/>
               </a:rPr>
-              <a:t>10 posts · 55,883 total views</a:t>
+              <a:t>10 posts · 56,234 total views</a:t>
             </a:r>
           </a:p>
         </p:txBody>
@@ -6475,7 +6475,7 @@
                 </a:solidFill>
                 <a:latin typeface="Georgia"/>
               </a:rPr>
-              <a:t>643</a:t>
+              <a:t>658</a:t>
             </a:r>
           </a:p>
         </p:txBody>
@@ -6543,7 +6543,7 @@
                 </a:solidFill>
                 <a:latin typeface="Helvetica Neue"/>
               </a:rPr>
-              <a:t>33 posts · 21,204 total views</a:t>
+              <a:t>35 posts · 23,033 total views</a:t>
             </a:r>
           </a:p>
         </p:txBody>
@@ -6699,7 +6699,7 @@
                 </a:solidFill>
                 <a:latin typeface="Georgia"/>
               </a:rPr>
-              <a:t>907</a:t>
+              <a:t>913</a:t>
             </a:r>
           </a:p>
         </p:txBody>
@@ -6767,7 +6767,7 @@
                 </a:solidFill>
                 <a:latin typeface="Helvetica Neue"/>
               </a:rPr>
-              <a:t>9 posts · 8,164 total views</a:t>
+              <a:t>9 posts · 8,214 total views</a:t>
             </a:r>
           </a:p>
         </p:txBody>
@@ -6923,7 +6923,7 @@
                 </a:solidFill>
                 <a:latin typeface="Georgia"/>
               </a:rPr>
-              <a:t>370</a:t>
+              <a:t>402</a:t>
             </a:r>
           </a:p>
         </p:txBody>
@@ -6991,7 +6991,7 @@
                 </a:solidFill>
                 <a:latin typeface="Helvetica Neue"/>
               </a:rPr>
-              <a:t>13 posts · 4,814 total views</a:t>
+              <a:t>17 posts · 6,834 total views</a:t>
             </a:r>
           </a:p>
         </p:txBody>
@@ -7147,7 +7147,7 @@
                 </a:solidFill>
                 <a:latin typeface="Georgia"/>
               </a:rPr>
-              <a:t>1,194</a:t>
+              <a:t>1,200</a:t>
             </a:r>
           </a:p>
         </p:txBody>
@@ -7215,7 +7215,7 @@
                 </a:solidFill>
                 <a:latin typeface="Helvetica Neue"/>
               </a:rPr>
-              <a:t>4 posts · 4,778 total views</a:t>
+              <a:t>4 posts · 4,802 total views</a:t>
             </a:r>
           </a:p>
         </p:txBody>
@@ -7371,7 +7371,7 @@
                 </a:solidFill>
                 <a:latin typeface="Georgia"/>
               </a:rPr>
-              <a:t>549</a:t>
+              <a:t>553</a:t>
             </a:r>
           </a:p>
         </p:txBody>
@@ -7439,7 +7439,7 @@
                 </a:solidFill>
                 <a:latin typeface="Helvetica Neue"/>
               </a:rPr>
-              <a:t>8 posts · 4,393 total views</a:t>
+              <a:t>8 posts · 4,423 total views</a:t>
             </a:r>
           </a:p>
         </p:txBody>
@@ -7595,7 +7595,7 @@
                 </a:solidFill>
                 <a:latin typeface="Georgia"/>
               </a:rPr>
-              <a:t>1,200</a:t>
+              <a:t>1,206</a:t>
             </a:r>
           </a:p>
         </p:txBody>
@@ -7663,7 +7663,7 @@
                 </a:solidFill>
                 <a:latin typeface="Helvetica Neue"/>
               </a:rPr>
-              <a:t>3 posts · 3,601 total views</a:t>
+              <a:t>3 posts · 3,617 total views</a:t>
             </a:r>
           </a:p>
         </p:txBody>
@@ -7819,7 +7819,7 @@
                 </a:solidFill>
                 <a:latin typeface="Georgia"/>
               </a:rPr>
-              <a:t>504</a:t>
+              <a:t>515</a:t>
             </a:r>
           </a:p>
         </p:txBody>
@@ -7887,7 +7887,7 @@
                 </a:solidFill>
                 <a:latin typeface="Helvetica Neue"/>
               </a:rPr>
-              <a:t>4 posts · 2,018 total views</a:t>
+              <a:t>4 posts · 2,061 total views</a:t>
             </a:r>
           </a:p>
         </p:txBody>
@@ -8513,7 +8513,7 @@
                 </a:solidFill>
                 <a:latin typeface="Helvetica Neue"/>
               </a:rPr>
-              <a:t>27,000</a:t>
+              <a:t>27,200</a:t>
             </a:r>
           </a:p>
         </p:txBody>
@@ -8547,7 +8547,7 @@
                 </a:solidFill>
                 <a:latin typeface="Helvetica Neue"/>
               </a:rPr>
-              <a:t>796</a:t>
+              <a:t>800</a:t>
             </a:r>
           </a:p>
         </p:txBody>
@@ -8805,7 +8805,7 @@
                 </a:solidFill>
                 <a:latin typeface="Helvetica Neue"/>
               </a:rPr>
-              <a:t>15,867</a:t>
+              <a:t>15,935</a:t>
             </a:r>
           </a:p>
         </p:txBody>
@@ -9053,7 +9053,7 @@
                 </a:solidFill>
                 <a:latin typeface="Helvetica Neue"/>
               </a:rPr>
-              <a:t>6,322</a:t>
+              <a:t>6,341</a:t>
             </a:r>
           </a:p>
         </p:txBody>
@@ -9301,7 +9301,7 @@
                 </a:solidFill>
                 <a:latin typeface="Helvetica Neue"/>
               </a:rPr>
-              <a:t>5,142</a:t>
+              <a:t>5,443</a:t>
             </a:r>
           </a:p>
         </p:txBody>
@@ -9335,7 +9335,7 @@
                 </a:solidFill>
                 <a:latin typeface="Helvetica Neue"/>
               </a:rPr>
-              <a:t>289</a:t>
+              <a:t>305</a:t>
             </a:r>
           </a:p>
         </p:txBody>
@@ -10137,7 +10137,7 @@
                 </a:solidFill>
                 <a:latin typeface="Helvetica Neue"/>
               </a:rPr>
-              <a:t>IG</a:t>
+              <a:t>TT</a:t>
             </a:r>
           </a:p>
         </p:txBody>
@@ -10171,7 +10171,7 @@
                 </a:solidFill>
                 <a:latin typeface="Helvetica Neue"/>
               </a:rPr>
-              <a:t>Election night 2006. Walking across the street, we realized we were in the </a:t>
+              <a:t>Championship game watch party! Downey Ave closed for the July 19th finals. </a:t>
             </a:r>
           </a:p>
         </p:txBody>
@@ -10205,7 +10205,7 @@
                 </a:solidFill>
                 <a:latin typeface="Helvetica Neue"/>
               </a:rPr>
-              <a:t>1,258</a:t>
+              <a:t>1,278</a:t>
             </a:r>
           </a:p>
         </p:txBody>
@@ -10239,7 +10239,7 @@
                 </a:solidFill>
                 <a:latin typeface="Helvetica Neue"/>
               </a:rPr>
-              <a:t>15</a:t>
+              <a:t>28</a:t>
             </a:r>
           </a:p>
         </p:txBody>
@@ -10273,7 +10273,7 @@
                 </a:solidFill>
                 <a:latin typeface="Helvetica Neue"/>
               </a:rPr>
-              <a:t>Elections</a:t>
+              <a:t>Fifa Positive</a:t>
             </a:r>
           </a:p>
         </p:txBody>
@@ -10549,7 +10549,7 @@
                 </a:solidFill>
                 <a:latin typeface="Helvetica Neue"/>
               </a:rPr>
-              <a:t>—  June posts (Jun 8–30 window): 131  →  July posts (Jul 1–31 window): 92</a:t>
+              <a:t>—  June posts (Jun 8–30 window): 131  →  July posts (Jul 1–31 window): 100</a:t>
             </a:r>
           </a:p>
         </p:txBody>

</xml_diff>

<commit_message>
Scheduled snapshot t14 (2026-07-22): fresh IG/FB/YT/TT + rebuilt decks
Co-Authored-By: Claude Opus 4.7 (1M context) <noreply@anthropic.com>
</commit_message>
<xml_diff>
--- a/MONTHLY_REPORT_2026-07.pptx
+++ b/MONTHLY_REPORT_2026-07.pptx
@@ -3613,7 +3613,7 @@
                 </a:solidFill>
                 <a:latin typeface="Georgia"/>
               </a:rPr>
-              <a:t>100</a:t>
+              <a:t>115</a:t>
             </a:r>
           </a:p>
         </p:txBody>
@@ -4063,7 +4063,7 @@
                 </a:solidFill>
                 <a:latin typeface="Georgia"/>
               </a:rPr>
-              <a:t>1,121 → 515</a:t>
+              <a:t>1,121 → 315</a:t>
             </a:r>
           </a:p>
         </p:txBody>
@@ -4097,7 +4097,7 @@
                 </a:solidFill>
                 <a:latin typeface="Helvetica Neue"/>
               </a:rPr>
-              <a:t>▼ -54%</a:t>
+              <a:t>▼ -72%</a:t>
             </a:r>
           </a:p>
         </p:txBody>
@@ -4287,7 +4287,7 @@
                 </a:solidFill>
                 <a:latin typeface="Georgia"/>
               </a:rPr>
-              <a:t>632 → 491</a:t>
+              <a:t>632 → 586</a:t>
             </a:r>
           </a:p>
         </p:txBody>
@@ -4321,7 +4321,7 @@
                 </a:solidFill>
                 <a:latin typeface="Helvetica Neue"/>
               </a:rPr>
-              <a:t>▼ -22%</a:t>
+              <a:t>▼ -7%</a:t>
             </a:r>
           </a:p>
         </p:txBody>
@@ -4709,7 +4709,7 @@
                 </a:solidFill>
                 <a:latin typeface="Georgia"/>
               </a:rPr>
-              <a:t>44,836</a:t>
+              <a:t>16,226</a:t>
             </a:r>
           </a:p>
         </p:txBody>
@@ -4743,7 +4743,7 @@
                 </a:solidFill>
                 <a:latin typeface="Helvetica Neue"/>
               </a:rPr>
-              <a:t>July views (33 posts)</a:t>
+              <a:t>July views (38 posts)</a:t>
             </a:r>
           </a:p>
         </p:txBody>
@@ -5045,7 +5045,7 @@
                 </a:solidFill>
                 <a:latin typeface="Georgia"/>
               </a:rPr>
-              <a:t>41,546</a:t>
+              <a:t>49,660</a:t>
             </a:r>
           </a:p>
         </p:txBody>
@@ -5079,7 +5079,7 @@
                 </a:solidFill>
                 <a:latin typeface="Helvetica Neue"/>
               </a:rPr>
-              <a:t>July views (30 posts)</a:t>
+              <a:t>July views (34 posts)</a:t>
             </a:r>
           </a:p>
         </p:txBody>
@@ -5381,7 +5381,7 @@
                 </a:solidFill>
                 <a:latin typeface="Georgia"/>
               </a:rPr>
-              <a:t>25,984</a:t>
+              <a:t>29,674</a:t>
             </a:r>
           </a:p>
         </p:txBody>
@@ -5415,7 +5415,7 @@
                 </a:solidFill>
                 <a:latin typeface="Helvetica Neue"/>
               </a:rPr>
-              <a:t>July views (34 posts)</a:t>
+              <a:t>July views (39 posts)</a:t>
             </a:r>
           </a:p>
         </p:txBody>
@@ -5717,7 +5717,7 @@
                 </a:solidFill>
                 <a:latin typeface="Georgia"/>
               </a:rPr>
-              <a:t>200</a:t>
+              <a:t>245</a:t>
             </a:r>
           </a:p>
         </p:txBody>
@@ -5751,7 +5751,7 @@
                 </a:solidFill>
                 <a:latin typeface="Helvetica Neue"/>
               </a:rPr>
-              <a:t>July views (3 posts)</a:t>
+              <a:t>July views (4 posts)</a:t>
             </a:r>
           </a:p>
         </p:txBody>
@@ -5863,7 +5863,7 @@
                 </a:solidFill>
                 <a:latin typeface="Helvetica Neue"/>
               </a:rPr>
-              <a:t>707</a:t>
+              <a:t>709</a:t>
             </a:r>
           </a:p>
         </p:txBody>
@@ -6251,7 +6251,7 @@
                 </a:solidFill>
                 <a:latin typeface="Georgia"/>
               </a:rPr>
-              <a:t>5,623</a:t>
+              <a:t>4,592</a:t>
             </a:r>
           </a:p>
         </p:txBody>
@@ -6319,7 +6319,7 @@
                 </a:solidFill>
                 <a:latin typeface="Helvetica Neue"/>
               </a:rPr>
-              <a:t>10 posts · 56,234 total views</a:t>
+              <a:t>10 posts · 45,921 total views</a:t>
             </a:r>
           </a:p>
         </p:txBody>
@@ -6475,7 +6475,7 @@
                 </a:solidFill>
                 <a:latin typeface="Georgia"/>
               </a:rPr>
-              <a:t>658</a:t>
+              <a:t>434</a:t>
             </a:r>
           </a:p>
         </p:txBody>
@@ -6543,7 +6543,7 @@
                 </a:solidFill>
                 <a:latin typeface="Helvetica Neue"/>
               </a:rPr>
-              <a:t>35 posts · 23,033 total views</a:t>
+              <a:t>44 posts · 19,091 total views</a:t>
             </a:r>
           </a:p>
         </p:txBody>
@@ -6699,7 +6699,7 @@
                 </a:solidFill>
                 <a:latin typeface="Georgia"/>
               </a:rPr>
-              <a:t>913</a:t>
+              <a:t>717</a:t>
             </a:r>
           </a:p>
         </p:txBody>
@@ -6767,7 +6767,7 @@
                 </a:solidFill>
                 <a:latin typeface="Helvetica Neue"/>
               </a:rPr>
-              <a:t>9 posts · 8,214 total views</a:t>
+              <a:t>14 posts · 10,037 total views</a:t>
             </a:r>
           </a:p>
         </p:txBody>
@@ -6923,7 +6923,7 @@
                 </a:solidFill>
                 <a:latin typeface="Georgia"/>
               </a:rPr>
-              <a:t>402</a:t>
+              <a:t>273</a:t>
             </a:r>
           </a:p>
         </p:txBody>
@@ -6991,7 +6991,7 @@
                 </a:solidFill>
                 <a:latin typeface="Helvetica Neue"/>
               </a:rPr>
-              <a:t>17 posts · 6,834 total views</a:t>
+              <a:t>17 posts · 4,637 total views</a:t>
             </a:r>
           </a:p>
         </p:txBody>
@@ -7147,7 +7147,7 @@
                 </a:solidFill>
                 <a:latin typeface="Georgia"/>
               </a:rPr>
-              <a:t>1,200</a:t>
+              <a:t>998</a:t>
             </a:r>
           </a:p>
         </p:txBody>
@@ -7215,7 +7215,7 @@
                 </a:solidFill>
                 <a:latin typeface="Helvetica Neue"/>
               </a:rPr>
-              <a:t>4 posts · 4,802 total views</a:t>
+              <a:t>4 posts · 3,992 total views</a:t>
             </a:r>
           </a:p>
         </p:txBody>
@@ -7371,7 +7371,7 @@
                 </a:solidFill>
                 <a:latin typeface="Georgia"/>
               </a:rPr>
-              <a:t>553</a:t>
+              <a:t>463</a:t>
             </a:r>
           </a:p>
         </p:txBody>
@@ -7439,7 +7439,7 @@
                 </a:solidFill>
                 <a:latin typeface="Helvetica Neue"/>
               </a:rPr>
-              <a:t>8 posts · 4,423 total views</a:t>
+              <a:t>8 posts · 3,707 total views</a:t>
             </a:r>
           </a:p>
         </p:txBody>
@@ -7727,7 +7727,7 @@
             <a:avLst/>
           </a:prstGeom>
           <a:solidFill>
-            <a:srgbClr val="1B7A43"/>
+            <a:srgbClr val="990011"/>
           </a:solidFill>
           <a:ln>
             <a:noFill/>
@@ -7781,11 +7781,11 @@
             <a:r>
               <a:rPr sz="900" b="1">
                 <a:solidFill>
-                  <a:srgbClr val="1B7A43"/>
-                </a:solidFill>
-                <a:latin typeface="Helvetica Neue"/>
-              </a:rPr>
-              <a:t>RESIDENT HIGHLIGHT</a:t>
+                  <a:srgbClr val="990011"/>
+                </a:solidFill>
+                <a:latin typeface="Helvetica Neue"/>
+              </a:rPr>
+              <a:t>AMERICAN PRIDE</a:t>
             </a:r>
           </a:p>
         </p:txBody>
@@ -7819,7 +7819,7 @@
                 </a:solidFill>
                 <a:latin typeface="Georgia"/>
               </a:rPr>
-              <a:t>515</a:t>
+              <a:t>586</a:t>
             </a:r>
           </a:p>
         </p:txBody>
@@ -7887,7 +7887,7 @@
                 </a:solidFill>
                 <a:latin typeface="Helvetica Neue"/>
               </a:rPr>
-              <a:t>4 posts · 2,061 total views</a:t>
+              <a:t>4 posts · 2,344 total views</a:t>
             </a:r>
           </a:p>
         </p:txBody>
@@ -8513,7 +8513,7 @@
                 </a:solidFill>
                 <a:latin typeface="Helvetica Neue"/>
               </a:rPr>
-              <a:t>27,200</a:t>
+              <a:t>27,300</a:t>
             </a:r>
           </a:p>
         </p:txBody>
@@ -8547,7 +8547,7 @@
                 </a:solidFill>
                 <a:latin typeface="Helvetica Neue"/>
               </a:rPr>
-              <a:t>800</a:t>
+              <a:t>805</a:t>
             </a:r>
           </a:p>
         </p:txBody>
@@ -8805,7 +8805,7 @@
                 </a:solidFill>
                 <a:latin typeface="Helvetica Neue"/>
               </a:rPr>
-              <a:t>15,935</a:t>
+              <a:t>7,180</a:t>
             </a:r>
           </a:p>
         </p:txBody>
@@ -8839,7 +8839,7 @@
                 </a:solidFill>
                 <a:latin typeface="Helvetica Neue"/>
               </a:rPr>
-              <a:t>262</a:t>
+              <a:t>264</a:t>
             </a:r>
           </a:p>
         </p:txBody>
@@ -9053,7 +9053,7 @@
                 </a:solidFill>
                 <a:latin typeface="Helvetica Neue"/>
               </a:rPr>
-              <a:t>6,341</a:t>
+              <a:t>6,355</a:t>
             </a:r>
           </a:p>
         </p:txBody>
@@ -9087,7 +9087,7 @@
                 </a:solidFill>
                 <a:latin typeface="Helvetica Neue"/>
               </a:rPr>
-              <a:t>45</a:t>
+              <a:t>46</a:t>
             </a:r>
           </a:p>
         </p:txBody>
@@ -9233,7 +9233,7 @@
                 </a:solidFill>
                 <a:latin typeface="Helvetica Neue"/>
               </a:rPr>
-              <a:t>IG</a:t>
+              <a:t>TT</a:t>
             </a:r>
           </a:p>
         </p:txBody>
@@ -9267,7 +9267,7 @@
                 </a:solidFill>
                 <a:latin typeface="Helvetica Neue"/>
               </a:rPr>
-              <a:t>Guilty or not guilty? It's immaterial. Our principles demand everyone deser</a:t>
+              <a:t>Pop's Wings just opened and it's a must-try! Their pastrami sandwich with s</a:t>
             </a:r>
           </a:p>
         </p:txBody>
@@ -9301,7 +9301,7 @@
                 </a:solidFill>
                 <a:latin typeface="Helvetica Neue"/>
               </a:rPr>
-              <a:t>5,443</a:t>
+              <a:t>5,704</a:t>
             </a:r>
           </a:p>
         </p:txBody>
@@ -9335,7 +9335,7 @@
                 </a:solidFill>
                 <a:latin typeface="Helvetica Neue"/>
               </a:rPr>
-              <a:t>305</a:t>
+              <a:t>268</a:t>
             </a:r>
           </a:p>
         </p:txBody>
@@ -9719,7 +9719,7 @@
                 </a:solidFill>
                 <a:latin typeface="Helvetica Neue"/>
               </a:rPr>
-              <a:t>A 2007 letter from a prominent citizen sent shockwaves through the communit</a:t>
+              <a:t>Downey City Council adopted a new Code of Ethics and Conduct for commission</a:t>
             </a:r>
           </a:p>
         </p:txBody>
@@ -9753,7 +9753,7 @@
                 </a:solidFill>
                 <a:latin typeface="Helvetica Neue"/>
               </a:rPr>
-              <a:t>1,357</a:t>
+              <a:t>1,416</a:t>
             </a:r>
           </a:p>
         </p:txBody>
@@ -9787,7 +9787,7 @@
                 </a:solidFill>
                 <a:latin typeface="Helvetica Neue"/>
               </a:rPr>
-              <a:t>8</a:t>
+              <a:t>18</a:t>
             </a:r>
           </a:p>
         </p:txBody>
@@ -9923,7 +9923,7 @@
                 </a:solidFill>
                 <a:latin typeface="Helvetica Neue"/>
               </a:rPr>
-              <a:t>The World Cup brings incredible passion as countries pour their hearts into</a:t>
+              <a:t>A 2007 letter from a prominent citizen sent shockwaves through the communit</a:t>
             </a:r>
           </a:p>
         </p:txBody>
@@ -9957,7 +9957,7 @@
                 </a:solidFill>
                 <a:latin typeface="Helvetica Neue"/>
               </a:rPr>
-              <a:t>1,348</a:t>
+              <a:t>1,357</a:t>
             </a:r>
           </a:p>
         </p:txBody>
@@ -9991,7 +9991,7 @@
                 </a:solidFill>
                 <a:latin typeface="Helvetica Neue"/>
               </a:rPr>
-              <a:t>5</a:t>
+              <a:t>8</a:t>
             </a:r>
           </a:p>
         </p:txBody>
@@ -10025,7 +10025,7 @@
                 </a:solidFill>
                 <a:latin typeface="Helvetica Neue"/>
               </a:rPr>
-              <a:t>Fifa Positive</a:t>
+              <a:t>Community Local</a:t>
             </a:r>
           </a:p>
         </p:txBody>
@@ -10137,7 +10137,7 @@
                 </a:solidFill>
                 <a:latin typeface="Helvetica Neue"/>
               </a:rPr>
-              <a:t>TT</a:t>
+              <a:t>FB</a:t>
             </a:r>
           </a:p>
         </p:txBody>
@@ -10171,7 +10171,7 @@
                 </a:solidFill>
                 <a:latin typeface="Helvetica Neue"/>
               </a:rPr>
-              <a:t>Championship game watch party! Downey Ave closed for the July 19th finals. </a:t>
+              <a:t>The World Cup brings incredible passion as countries pour their hearts into</a:t>
             </a:r>
           </a:p>
         </p:txBody>
@@ -10205,7 +10205,7 @@
                 </a:solidFill>
                 <a:latin typeface="Helvetica Neue"/>
               </a:rPr>
-              <a:t>1,278</a:t>
+              <a:t>1,348</a:t>
             </a:r>
           </a:p>
         </p:txBody>
@@ -10239,7 +10239,7 @@
                 </a:solidFill>
                 <a:latin typeface="Helvetica Neue"/>
               </a:rPr>
-              <a:t>28</a:t>
+              <a:t>5</a:t>
             </a:r>
           </a:p>
         </p:txBody>
@@ -10549,7 +10549,7 @@
                 </a:solidFill>
                 <a:latin typeface="Helvetica Neue"/>
               </a:rPr>
-              <a:t>—  June posts (Jun 8–30 window): 131  →  July posts (Jul 1–31 window): 100</a:t>
+              <a:t>—  June posts (Jun 8–30 window): 131  →  July posts (Jul 1–31 window): 115</a:t>
             </a:r>
           </a:p>
         </p:txBody>

</xml_diff>

<commit_message>
Scheduled snapshot t15 (2026-07-24): fresh IG/FB/YT/TT + rebuilt decks
Co-Authored-By: Claude Opus 4.7 (1M context) <noreply@anthropic.com>
</commit_message>
<xml_diff>
--- a/MONTHLY_REPORT_2026-07.pptx
+++ b/MONTHLY_REPORT_2026-07.pptx
@@ -3613,7 +3613,7 @@
                 </a:solidFill>
                 <a:latin typeface="Georgia"/>
               </a:rPr>
-              <a:t>115</a:t>
+              <a:t>127</a:t>
             </a:r>
           </a:p>
         </p:txBody>
@@ -4063,7 +4063,7 @@
                 </a:solidFill>
                 <a:latin typeface="Georgia"/>
               </a:rPr>
-              <a:t>1,121 → 315</a:t>
+              <a:t>1,121 → 318</a:t>
             </a:r>
           </a:p>
         </p:txBody>
@@ -4287,7 +4287,7 @@
                 </a:solidFill>
                 <a:latin typeface="Georgia"/>
               </a:rPr>
-              <a:t>632 → 586</a:t>
+              <a:t>632 → 6,083</a:t>
             </a:r>
           </a:p>
         </p:txBody>
@@ -4317,11 +4317,11 @@
             <a:r>
               <a:rPr sz="1800" b="1">
                 <a:solidFill>
-                  <a:srgbClr val="990011"/>
-                </a:solidFill>
-                <a:latin typeface="Helvetica Neue"/>
-              </a:rPr>
-              <a:t>▼ -7%</a:t>
+                  <a:srgbClr val="1B7A43"/>
+                </a:solidFill>
+                <a:latin typeface="Helvetica Neue"/>
+              </a:rPr>
+              <a:t>▲ +863%</a:t>
             </a:r>
           </a:p>
         </p:txBody>
@@ -4743,7 +4743,7 @@
                 </a:solidFill>
                 <a:latin typeface="Helvetica Neue"/>
               </a:rPr>
-              <a:t>July views (38 posts)</a:t>
+              <a:t>July views (42 posts)</a:t>
             </a:r>
           </a:p>
         </p:txBody>
@@ -5045,7 +5045,7 @@
                 </a:solidFill>
                 <a:latin typeface="Georgia"/>
               </a:rPr>
-              <a:t>49,660</a:t>
+              <a:t>81,485</a:t>
             </a:r>
           </a:p>
         </p:txBody>
@@ -5079,7 +5079,7 @@
                 </a:solidFill>
                 <a:latin typeface="Helvetica Neue"/>
               </a:rPr>
-              <a:t>July views (34 posts)</a:t>
+              <a:t>July views (38 posts)</a:t>
             </a:r>
           </a:p>
         </p:txBody>
@@ -5381,7 +5381,7 @@
                 </a:solidFill>
                 <a:latin typeface="Georgia"/>
               </a:rPr>
-              <a:t>29,674</a:t>
+              <a:t>32,797</a:t>
             </a:r>
           </a:p>
         </p:txBody>
@@ -5415,7 +5415,7 @@
                 </a:solidFill>
                 <a:latin typeface="Helvetica Neue"/>
               </a:rPr>
-              <a:t>July views (39 posts)</a:t>
+              <a:t>July views (43 posts)</a:t>
             </a:r>
           </a:p>
         </p:txBody>
@@ -5717,7 +5717,7 @@
                 </a:solidFill>
                 <a:latin typeface="Georgia"/>
               </a:rPr>
-              <a:t>245</a:t>
+              <a:t>266</a:t>
             </a:r>
           </a:p>
         </p:txBody>
@@ -5863,7 +5863,7 @@
                 </a:solidFill>
                 <a:latin typeface="Helvetica Neue"/>
               </a:rPr>
-              <a:t>709</a:t>
+              <a:t>715</a:t>
             </a:r>
           </a:p>
         </p:txBody>
@@ -6251,7 +6251,7 @@
                 </a:solidFill>
                 <a:latin typeface="Georgia"/>
               </a:rPr>
-              <a:t>4,592</a:t>
+              <a:t>4,603</a:t>
             </a:r>
           </a:p>
         </p:txBody>
@@ -6319,7 +6319,7 @@
                 </a:solidFill>
                 <a:latin typeface="Helvetica Neue"/>
               </a:rPr>
-              <a:t>10 posts · 45,921 total views</a:t>
+              <a:t>10 posts · 46,034 total views</a:t>
             </a:r>
           </a:p>
         </p:txBody>
@@ -6383,7 +6383,7 @@
             <a:avLst/>
           </a:prstGeom>
           <a:solidFill>
-            <a:srgbClr val="6B7082"/>
+            <a:srgbClr val="990011"/>
           </a:solidFill>
           <a:ln>
             <a:noFill/>
@@ -6437,11 +6437,11 @@
             <a:r>
               <a:rPr sz="900" b="1">
                 <a:solidFill>
-                  <a:srgbClr val="6B7082"/>
-                </a:solidFill>
-                <a:latin typeface="Helvetica Neue"/>
-              </a:rPr>
-              <a:t>OTHER</a:t>
+                  <a:srgbClr val="990011"/>
+                </a:solidFill>
+                <a:latin typeface="Helvetica Neue"/>
+              </a:rPr>
+              <a:t>AMERICAN PRIDE</a:t>
             </a:r>
           </a:p>
         </p:txBody>
@@ -6475,7 +6475,7 @@
                 </a:solidFill>
                 <a:latin typeface="Georgia"/>
               </a:rPr>
-              <a:t>434</a:t>
+              <a:t>6,083</a:t>
             </a:r>
           </a:p>
         </p:txBody>
@@ -6543,7 +6543,7 @@
                 </a:solidFill>
                 <a:latin typeface="Helvetica Neue"/>
               </a:rPr>
-              <a:t>44 posts · 19,091 total views</a:t>
+              <a:t>5 posts · 30,416 total views</a:t>
             </a:r>
           </a:p>
         </p:txBody>
@@ -6607,7 +6607,7 @@
             <a:avLst/>
           </a:prstGeom>
           <a:solidFill>
-            <a:srgbClr val="141833"/>
+            <a:srgbClr val="6B7082"/>
           </a:solidFill>
           <a:ln>
             <a:noFill/>
@@ -6661,11 +6661,11 @@
             <a:r>
               <a:rPr sz="900" b="1">
                 <a:solidFill>
-                  <a:srgbClr val="141833"/>
-                </a:solidFill>
-                <a:latin typeface="Helvetica Neue"/>
-              </a:rPr>
-              <a:t>COMMUNITY LOCAL</a:t>
+                  <a:srgbClr val="6B7082"/>
+                </a:solidFill>
+                <a:latin typeface="Helvetica Neue"/>
+              </a:rPr>
+              <a:t>OTHER</a:t>
             </a:r>
           </a:p>
         </p:txBody>
@@ -6699,7 +6699,7 @@
                 </a:solidFill>
                 <a:latin typeface="Georgia"/>
               </a:rPr>
-              <a:t>717</a:t>
+              <a:t>464</a:t>
             </a:r>
           </a:p>
         </p:txBody>
@@ -6767,7 +6767,7 @@
                 </a:solidFill>
                 <a:latin typeface="Helvetica Neue"/>
               </a:rPr>
-              <a:t>14 posts · 10,037 total views</a:t>
+              <a:t>48 posts · 22,269 total views</a:t>
             </a:r>
           </a:p>
         </p:txBody>
@@ -6831,7 +6831,7 @@
             <a:avLst/>
           </a:prstGeom>
           <a:solidFill>
-            <a:srgbClr val="2F3C7E"/>
+            <a:srgbClr val="141833"/>
           </a:solidFill>
           <a:ln>
             <a:noFill/>
@@ -6885,11 +6885,11 @@
             <a:r>
               <a:rPr sz="900" b="1">
                 <a:solidFill>
-                  <a:srgbClr val="2F3C7E"/>
-                </a:solidFill>
-                <a:latin typeface="Helvetica Neue"/>
-              </a:rPr>
-              <a:t>JUDICIAL</a:t>
+                  <a:srgbClr val="141833"/>
+                </a:solidFill>
+                <a:latin typeface="Helvetica Neue"/>
+              </a:rPr>
+              <a:t>COMMUNITY LOCAL</a:t>
             </a:r>
           </a:p>
         </p:txBody>
@@ -6923,7 +6923,7 @@
                 </a:solidFill>
                 <a:latin typeface="Georgia"/>
               </a:rPr>
-              <a:t>273</a:t>
+              <a:t>727</a:t>
             </a:r>
           </a:p>
         </p:txBody>
@@ -6991,7 +6991,7 @@
                 </a:solidFill>
                 <a:latin typeface="Helvetica Neue"/>
               </a:rPr>
-              <a:t>17 posts · 4,637 total views</a:t>
+              <a:t>15 posts · 10,899 total views</a:t>
             </a:r>
           </a:p>
         </p:txBody>
@@ -7055,7 +7055,7 @@
             <a:avLst/>
           </a:prstGeom>
           <a:solidFill>
-            <a:srgbClr val="C9A227"/>
+            <a:srgbClr val="2F3C7E"/>
           </a:solidFill>
           <a:ln>
             <a:noFill/>
@@ -7109,11 +7109,11 @@
             <a:r>
               <a:rPr sz="900" b="1">
                 <a:solidFill>
-                  <a:srgbClr val="C9A227"/>
-                </a:solidFill>
-                <a:latin typeface="Helvetica Neue"/>
-              </a:rPr>
-              <a:t>DOWNTOWN DEVELOPMENT</a:t>
+                  <a:srgbClr val="2F3C7E"/>
+                </a:solidFill>
+                <a:latin typeface="Helvetica Neue"/>
+              </a:rPr>
+              <a:t>JUDICIAL</a:t>
             </a:r>
           </a:p>
         </p:txBody>
@@ -7147,7 +7147,7 @@
                 </a:solidFill>
                 <a:latin typeface="Georgia"/>
               </a:rPr>
-              <a:t>998</a:t>
+              <a:t>283</a:t>
             </a:r>
           </a:p>
         </p:txBody>
@@ -7215,7 +7215,7 @@
                 </a:solidFill>
                 <a:latin typeface="Helvetica Neue"/>
               </a:rPr>
-              <a:t>4 posts · 3,992 total views</a:t>
+              <a:t>17 posts · 4,804 total views</a:t>
             </a:r>
           </a:p>
         </p:txBody>
@@ -7279,7 +7279,7 @@
             <a:avLst/>
           </a:prstGeom>
           <a:solidFill>
-            <a:srgbClr val="141833"/>
+            <a:srgbClr val="2F3C7E"/>
           </a:solidFill>
           <a:ln>
             <a:noFill/>
@@ -7333,11 +7333,11 @@
             <a:r>
               <a:rPr sz="900" b="1">
                 <a:solidFill>
-                  <a:srgbClr val="141833"/>
-                </a:solidFill>
-                <a:latin typeface="Helvetica Neue"/>
-              </a:rPr>
-              <a:t>COMMUNITY EVENTS</a:t>
+                  <a:srgbClr val="2F3C7E"/>
+                </a:solidFill>
+                <a:latin typeface="Helvetica Neue"/>
+              </a:rPr>
+              <a:t>ELECTIONS</a:t>
             </a:r>
           </a:p>
         </p:txBody>
@@ -7371,7 +7371,7 @@
                 </a:solidFill>
                 <a:latin typeface="Georgia"/>
               </a:rPr>
-              <a:t>463</a:t>
+              <a:t>1,004</a:t>
             </a:r>
           </a:p>
         </p:txBody>
@@ -7439,7 +7439,7 @@
                 </a:solidFill>
                 <a:latin typeface="Helvetica Neue"/>
               </a:rPr>
-              <a:t>8 posts · 3,707 total views</a:t>
+              <a:t>4 posts · 4,018 total views</a:t>
             </a:r>
           </a:p>
         </p:txBody>
@@ -7503,7 +7503,7 @@
             <a:avLst/>
           </a:prstGeom>
           <a:solidFill>
-            <a:srgbClr val="2F3C7E"/>
+            <a:srgbClr val="C9A227"/>
           </a:solidFill>
           <a:ln>
             <a:noFill/>
@@ -7557,11 +7557,11 @@
             <a:r>
               <a:rPr sz="900" b="1">
                 <a:solidFill>
-                  <a:srgbClr val="2F3C7E"/>
-                </a:solidFill>
-                <a:latin typeface="Helvetica Neue"/>
-              </a:rPr>
-              <a:t>ELECTIONS</a:t>
+                  <a:srgbClr val="C9A227"/>
+                </a:solidFill>
+                <a:latin typeface="Helvetica Neue"/>
+              </a:rPr>
+              <a:t>DOWNTOWN DEVELOPMENT</a:t>
             </a:r>
           </a:p>
         </p:txBody>
@@ -7595,7 +7595,7 @@
                 </a:solidFill>
                 <a:latin typeface="Georgia"/>
               </a:rPr>
-              <a:t>1,206</a:t>
+              <a:t>1,002</a:t>
             </a:r>
           </a:p>
         </p:txBody>
@@ -7663,7 +7663,7 @@
                 </a:solidFill>
                 <a:latin typeface="Helvetica Neue"/>
               </a:rPr>
-              <a:t>3 posts · 3,617 total views</a:t>
+              <a:t>4 posts · 4,006 total views</a:t>
             </a:r>
           </a:p>
         </p:txBody>
@@ -7727,7 +7727,7 @@
             <a:avLst/>
           </a:prstGeom>
           <a:solidFill>
-            <a:srgbClr val="990011"/>
+            <a:srgbClr val="141833"/>
           </a:solidFill>
           <a:ln>
             <a:noFill/>
@@ -7781,11 +7781,11 @@
             <a:r>
               <a:rPr sz="900" b="1">
                 <a:solidFill>
-                  <a:srgbClr val="990011"/>
-                </a:solidFill>
-                <a:latin typeface="Helvetica Neue"/>
-              </a:rPr>
-              <a:t>AMERICAN PRIDE</a:t>
+                  <a:srgbClr val="141833"/>
+                </a:solidFill>
+                <a:latin typeface="Helvetica Neue"/>
+              </a:rPr>
+              <a:t>COMMUNITY EVENTS</a:t>
             </a:r>
           </a:p>
         </p:txBody>
@@ -7819,7 +7819,7 @@
                 </a:solidFill>
                 <a:latin typeface="Georgia"/>
               </a:rPr>
-              <a:t>586</a:t>
+              <a:t>465</a:t>
             </a:r>
           </a:p>
         </p:txBody>
@@ -7887,7 +7887,7 @@
                 </a:solidFill>
                 <a:latin typeface="Helvetica Neue"/>
               </a:rPr>
-              <a:t>4 posts · 2,344 total views</a:t>
+              <a:t>8 posts · 3,722 total views</a:t>
             </a:r>
           </a:p>
         </p:txBody>
@@ -8479,7 +8479,7 @@
                 </a:solidFill>
                 <a:latin typeface="Helvetica Neue"/>
               </a:rPr>
-              <a:t>Watch party in Stonewood Mall! Over 25,000 people showed up for this epic e</a:t>
+              <a:t>Combat jobs aren't for everyone. See how your MOS determines deployment lik</a:t>
             </a:r>
           </a:p>
         </p:txBody>
@@ -8513,7 +8513,7 @@
                 </a:solidFill>
                 <a:latin typeface="Helvetica Neue"/>
               </a:rPr>
-              <a:t>27,300</a:t>
+              <a:t>28,000</a:t>
             </a:r>
           </a:p>
         </p:txBody>
@@ -8547,7 +8547,7 @@
                 </a:solidFill>
                 <a:latin typeface="Helvetica Neue"/>
               </a:rPr>
-              <a:t>805</a:t>
+              <a:t>1,700</a:t>
             </a:r>
           </a:p>
         </p:txBody>
@@ -8581,7 +8581,7 @@
                 </a:solidFill>
                 <a:latin typeface="Helvetica Neue"/>
               </a:rPr>
-              <a:t>Fifa Positive</a:t>
+              <a:t>American Pride</a:t>
             </a:r>
           </a:p>
         </p:txBody>
@@ -8737,7 +8737,7 @@
                 </a:solidFill>
                 <a:latin typeface="Helvetica Neue"/>
               </a:rPr>
-              <a:t>IG</a:t>
+              <a:t>TT</a:t>
             </a:r>
           </a:p>
         </p:txBody>
@@ -8771,7 +8771,7 @@
                 </a:solidFill>
                 <a:latin typeface="Helvetica Neue"/>
               </a:rPr>
-              <a:t>25,000+ people gathered for a watch party at Stonewood Mall! Despite the $3</a:t>
+              <a:t>Watch party in Stonewood Mall! Over 25,000 people showed up for this epic e</a:t>
             </a:r>
           </a:p>
         </p:txBody>
@@ -8805,7 +8805,7 @@
                 </a:solidFill>
                 <a:latin typeface="Helvetica Neue"/>
               </a:rPr>
-              <a:t>7,180</a:t>
+              <a:t>27,400</a:t>
             </a:r>
           </a:p>
         </p:txBody>
@@ -8839,7 +8839,7 @@
                 </a:solidFill>
                 <a:latin typeface="Helvetica Neue"/>
               </a:rPr>
-              <a:t>264</a:t>
+              <a:t>806</a:t>
             </a:r>
           </a:p>
         </p:txBody>
@@ -8985,7 +8985,7 @@
                 </a:solidFill>
                 <a:latin typeface="Helvetica Neue"/>
               </a:rPr>
-              <a:t>FB</a:t>
+              <a:t>TT</a:t>
             </a:r>
           </a:p>
         </p:txBody>
@@ -9019,7 +9019,7 @@
                 </a:solidFill>
                 <a:latin typeface="Helvetica Neue"/>
               </a:rPr>
-              <a:t>Over 25,000 people gathered at Stonewood Mall for a massive watch party. De</a:t>
+              <a:t>Pop's Wings just opened and it's a must-try! Their pastrami sandwich with s</a:t>
             </a:r>
           </a:p>
         </p:txBody>
@@ -9053,7 +9053,7 @@
                 </a:solidFill>
                 <a:latin typeface="Helvetica Neue"/>
               </a:rPr>
-              <a:t>6,355</a:t>
+              <a:t>7,360</a:t>
             </a:r>
           </a:p>
         </p:txBody>
@@ -9087,7 +9087,7 @@
                 </a:solidFill>
                 <a:latin typeface="Helvetica Neue"/>
               </a:rPr>
-              <a:t>46</a:t>
+              <a:t>364</a:t>
             </a:r>
           </a:p>
         </p:txBody>
@@ -9121,7 +9121,7 @@
                 </a:solidFill>
                 <a:latin typeface="Helvetica Neue"/>
               </a:rPr>
-              <a:t>Fifa Positive</a:t>
+              <a:t>Other</a:t>
             </a:r>
           </a:p>
         </p:txBody>
@@ -9233,7 +9233,7 @@
                 </a:solidFill>
                 <a:latin typeface="Helvetica Neue"/>
               </a:rPr>
-              <a:t>TT</a:t>
+              <a:t>IG</a:t>
             </a:r>
           </a:p>
         </p:txBody>
@@ -9267,7 +9267,7 @@
                 </a:solidFill>
                 <a:latin typeface="Helvetica Neue"/>
               </a:rPr>
-              <a:t>Pop's Wings just opened and it's a must-try! Their pastrami sandwich with s</a:t>
+              <a:t>25,000+ people gathered for a watch party at Stonewood Mall! Despite the $3</a:t>
             </a:r>
           </a:p>
         </p:txBody>
@@ -9301,7 +9301,7 @@
                 </a:solidFill>
                 <a:latin typeface="Helvetica Neue"/>
               </a:rPr>
-              <a:t>5,704</a:t>
+              <a:t>7,180</a:t>
             </a:r>
           </a:p>
         </p:txBody>
@@ -9335,7 +9335,7 @@
                 </a:solidFill>
                 <a:latin typeface="Helvetica Neue"/>
               </a:rPr>
-              <a:t>268</a:t>
+              <a:t>264</a:t>
             </a:r>
           </a:p>
         </p:txBody>
@@ -9369,7 +9369,7 @@
                 </a:solidFill>
                 <a:latin typeface="Helvetica Neue"/>
               </a:rPr>
-              <a:t>Other</a:t>
+              <a:t>Fifa Positive</a:t>
             </a:r>
           </a:p>
         </p:txBody>
@@ -9437,7 +9437,7 @@
                 </a:solidFill>
                 <a:latin typeface="Helvetica Neue"/>
               </a:rPr>
-              <a:t>IG</a:t>
+              <a:t>FB</a:t>
             </a:r>
           </a:p>
         </p:txBody>
@@ -9471,7 +9471,7 @@
                 </a:solidFill>
                 <a:latin typeface="Helvetica Neue"/>
               </a:rPr>
-              <a:t>20 years later, this letter still resonates. It sparked the Downtown Improv</a:t>
+              <a:t>Over 25,000 people gathered at Stonewood Mall for a massive watch party. De</a:t>
             </a:r>
           </a:p>
         </p:txBody>
@@ -9505,7 +9505,7 @@
                 </a:solidFill>
                 <a:latin typeface="Helvetica Neue"/>
               </a:rPr>
-              <a:t>2,390</a:t>
+              <a:t>6,355</a:t>
             </a:r>
           </a:p>
         </p:txBody>
@@ -9539,7 +9539,7 @@
                 </a:solidFill>
                 <a:latin typeface="Helvetica Neue"/>
               </a:rPr>
-              <a:t>39</a:t>
+              <a:t>46</a:t>
             </a:r>
           </a:p>
         </p:txBody>
@@ -9573,7 +9573,7 @@
                 </a:solidFill>
                 <a:latin typeface="Helvetica Neue"/>
               </a:rPr>
-              <a:t>Downtown Development</a:t>
+              <a:t>Fifa Positive</a:t>
             </a:r>
           </a:p>
         </p:txBody>
@@ -9685,7 +9685,7 @@
                 </a:solidFill>
                 <a:latin typeface="Helvetica Neue"/>
               </a:rPr>
-              <a:t>FB</a:t>
+              <a:t>IG</a:t>
             </a:r>
           </a:p>
         </p:txBody>
@@ -9719,7 +9719,7 @@
                 </a:solidFill>
                 <a:latin typeface="Helvetica Neue"/>
               </a:rPr>
-              <a:t>Downey City Council adopted a new Code of Ethics and Conduct for commission</a:t>
+              <a:t>20 years later, this letter still resonates. It sparked the Downtown Improv</a:t>
             </a:r>
           </a:p>
         </p:txBody>
@@ -9753,7 +9753,7 @@
                 </a:solidFill>
                 <a:latin typeface="Helvetica Neue"/>
               </a:rPr>
-              <a:t>1,416</a:t>
+              <a:t>2,390</a:t>
             </a:r>
           </a:p>
         </p:txBody>
@@ -9787,7 +9787,7 @@
                 </a:solidFill>
                 <a:latin typeface="Helvetica Neue"/>
               </a:rPr>
-              <a:t>18</a:t>
+              <a:t>39</a:t>
             </a:r>
           </a:p>
         </p:txBody>
@@ -9821,7 +9821,7 @@
                 </a:solidFill>
                 <a:latin typeface="Helvetica Neue"/>
               </a:rPr>
-              <a:t>Community Local</a:t>
+              <a:t>Downtown Development</a:t>
             </a:r>
           </a:p>
         </p:txBody>
@@ -9923,7 +9923,7 @@
                 </a:solidFill>
                 <a:latin typeface="Helvetica Neue"/>
               </a:rPr>
-              <a:t>A 2007 letter from a prominent citizen sent shockwaves through the communit</a:t>
+              <a:t>Discover Pop's Wings, a family-owned gem in Downey serving up more than jus</a:t>
             </a:r>
           </a:p>
         </p:txBody>
@@ -9957,7 +9957,7 @@
                 </a:solidFill>
                 <a:latin typeface="Helvetica Neue"/>
               </a:rPr>
-              <a:t>1,357</a:t>
+              <a:t>1,641</a:t>
             </a:r>
           </a:p>
         </p:txBody>
@@ -9991,7 +9991,7 @@
                 </a:solidFill>
                 <a:latin typeface="Helvetica Neue"/>
               </a:rPr>
-              <a:t>8</a:t>
+              <a:t>23</a:t>
             </a:r>
           </a:p>
         </p:txBody>
@@ -10171,7 +10171,7 @@
                 </a:solidFill>
                 <a:latin typeface="Helvetica Neue"/>
               </a:rPr>
-              <a:t>The World Cup brings incredible passion as countries pour their hearts into</a:t>
+              <a:t>Downey City Council adopted a new Code of Ethics and Conduct for commission</a:t>
             </a:r>
           </a:p>
         </p:txBody>
@@ -10205,7 +10205,7 @@
                 </a:solidFill>
                 <a:latin typeface="Helvetica Neue"/>
               </a:rPr>
-              <a:t>1,348</a:t>
+              <a:t>1,584</a:t>
             </a:r>
           </a:p>
         </p:txBody>
@@ -10239,7 +10239,7 @@
                 </a:solidFill>
                 <a:latin typeface="Helvetica Neue"/>
               </a:rPr>
-              <a:t>5</a:t>
+              <a:t>19</a:t>
             </a:r>
           </a:p>
         </p:txBody>
@@ -10273,7 +10273,7 @@
                 </a:solidFill>
                 <a:latin typeface="Helvetica Neue"/>
               </a:rPr>
-              <a:t>Fifa Positive</a:t>
+              <a:t>Community Local</a:t>
             </a:r>
           </a:p>
         </p:txBody>
@@ -10549,7 +10549,7 @@
                 </a:solidFill>
                 <a:latin typeface="Helvetica Neue"/>
               </a:rPr>
-              <a:t>—  June posts (Jun 8–30 window): 131  →  July posts (Jul 1–31 window): 115</a:t>
+              <a:t>—  June posts (Jun 8–30 window): 131  →  July posts (Jul 1–31 window): 127</a:t>
             </a:r>
           </a:p>
         </p:txBody>

</xml_diff>